<commit_message>
fixing typos in week4 path diagrams
</commit_message>
<xml_diff>
--- a/lectures/week4/latex/figures/cfa_path_diagram_with_symbols.pptx
+++ b/lectures/week4/latex/figures/cfa_path_diagram_with_symbols.pptx
@@ -261,7 +261,7 @@
           <a:p>
             <a:fld id="{FDF37C11-8503-4379-84C1-0F4598AA500E}" type="datetimeFigureOut">
               <a:rPr lang="nl-NL" smtClean="0"/>
-              <a:t>2-10-2024</a:t>
+              <a:t>25-9-2025</a:t>
             </a:fld>
             <a:endParaRPr lang="nl-NL"/>
           </a:p>
@@ -431,7 +431,7 @@
           <a:p>
             <a:fld id="{FDF37C11-8503-4379-84C1-0F4598AA500E}" type="datetimeFigureOut">
               <a:rPr lang="nl-NL" smtClean="0"/>
-              <a:t>2-10-2024</a:t>
+              <a:t>25-9-2025</a:t>
             </a:fld>
             <a:endParaRPr lang="nl-NL"/>
           </a:p>
@@ -611,7 +611,7 @@
           <a:p>
             <a:fld id="{FDF37C11-8503-4379-84C1-0F4598AA500E}" type="datetimeFigureOut">
               <a:rPr lang="nl-NL" smtClean="0"/>
-              <a:t>2-10-2024</a:t>
+              <a:t>25-9-2025</a:t>
             </a:fld>
             <a:endParaRPr lang="nl-NL"/>
           </a:p>
@@ -781,7 +781,7 @@
           <a:p>
             <a:fld id="{FDF37C11-8503-4379-84C1-0F4598AA500E}" type="datetimeFigureOut">
               <a:rPr lang="nl-NL" smtClean="0"/>
-              <a:t>2-10-2024</a:t>
+              <a:t>25-9-2025</a:t>
             </a:fld>
             <a:endParaRPr lang="nl-NL"/>
           </a:p>
@@ -1027,7 +1027,7 @@
           <a:p>
             <a:fld id="{FDF37C11-8503-4379-84C1-0F4598AA500E}" type="datetimeFigureOut">
               <a:rPr lang="nl-NL" smtClean="0"/>
-              <a:t>2-10-2024</a:t>
+              <a:t>25-9-2025</a:t>
             </a:fld>
             <a:endParaRPr lang="nl-NL"/>
           </a:p>
@@ -1259,7 +1259,7 @@
           <a:p>
             <a:fld id="{FDF37C11-8503-4379-84C1-0F4598AA500E}" type="datetimeFigureOut">
               <a:rPr lang="nl-NL" smtClean="0"/>
-              <a:t>2-10-2024</a:t>
+              <a:t>25-9-2025</a:t>
             </a:fld>
             <a:endParaRPr lang="nl-NL"/>
           </a:p>
@@ -1626,7 +1626,7 @@
           <a:p>
             <a:fld id="{FDF37C11-8503-4379-84C1-0F4598AA500E}" type="datetimeFigureOut">
               <a:rPr lang="nl-NL" smtClean="0"/>
-              <a:t>2-10-2024</a:t>
+              <a:t>25-9-2025</a:t>
             </a:fld>
             <a:endParaRPr lang="nl-NL"/>
           </a:p>
@@ -1744,7 +1744,7 @@
           <a:p>
             <a:fld id="{FDF37C11-8503-4379-84C1-0F4598AA500E}" type="datetimeFigureOut">
               <a:rPr lang="nl-NL" smtClean="0"/>
-              <a:t>2-10-2024</a:t>
+              <a:t>25-9-2025</a:t>
             </a:fld>
             <a:endParaRPr lang="nl-NL"/>
           </a:p>
@@ -1839,7 +1839,7 @@
           <a:p>
             <a:fld id="{FDF37C11-8503-4379-84C1-0F4598AA500E}" type="datetimeFigureOut">
               <a:rPr lang="nl-NL" smtClean="0"/>
-              <a:t>2-10-2024</a:t>
+              <a:t>25-9-2025</a:t>
             </a:fld>
             <a:endParaRPr lang="nl-NL"/>
           </a:p>
@@ -2116,7 +2116,7 @@
           <a:p>
             <a:fld id="{FDF37C11-8503-4379-84C1-0F4598AA500E}" type="datetimeFigureOut">
               <a:rPr lang="nl-NL" smtClean="0"/>
-              <a:t>2-10-2024</a:t>
+              <a:t>25-9-2025</a:t>
             </a:fld>
             <a:endParaRPr lang="nl-NL"/>
           </a:p>
@@ -2373,7 +2373,7 @@
           <a:p>
             <a:fld id="{FDF37C11-8503-4379-84C1-0F4598AA500E}" type="datetimeFigureOut">
               <a:rPr lang="nl-NL" smtClean="0"/>
-              <a:t>2-10-2024</a:t>
+              <a:t>25-9-2025</a:t>
             </a:fld>
             <a:endParaRPr lang="nl-NL"/>
           </a:p>
@@ -2586,7 +2586,7 @@
           <a:p>
             <a:fld id="{FDF37C11-8503-4379-84C1-0F4598AA500E}" type="datetimeFigureOut">
               <a:rPr lang="nl-NL" smtClean="0"/>
-              <a:t>2-10-2024</a:t>
+              <a:t>25-9-2025</a:t>
             </a:fld>
             <a:endParaRPr lang="nl-NL"/>
           </a:p>
@@ -21380,16 +21380,7 @@
                     </a:solidFill>
                     <a:latin typeface="Times New Roman"/>
                   </a:rPr>
-                  <a:t>O</a:t>
-                </a:r>
-                <a:r>
-                  <a:rPr lang="en-US" sz="1400" b="0" strike="noStrike" spc="-1" dirty="0">
-                    <a:solidFill>
-                      <a:schemeClr val="dk1"/>
-                    </a:solidFill>
-                    <a:latin typeface="Times New Roman"/>
-                  </a:rPr>
-                  <a:t>4</a:t>
+                  <a:t>O5</a:t>
                 </a:r>
                 <a:endParaRPr lang="en-DK" sz="1400" b="0" strike="noStrike" spc="-1" dirty="0">
                   <a:solidFill>
@@ -26906,16 +26897,7 @@
                     </a:solidFill>
                     <a:latin typeface="Times New Roman"/>
                   </a:rPr>
-                  <a:t>O</a:t>
-                </a:r>
-                <a:r>
-                  <a:rPr lang="en-US" sz="1400" b="0" strike="noStrike" spc="-1" dirty="0">
-                    <a:solidFill>
-                      <a:schemeClr val="dk1"/>
-                    </a:solidFill>
-                    <a:latin typeface="Times New Roman"/>
-                  </a:rPr>
-                  <a:t>4</a:t>
+                  <a:t>O5</a:t>
                 </a:r>
                 <a:endParaRPr lang="en-DK" sz="1400" b="0" strike="noStrike" spc="-1" dirty="0">
                   <a:solidFill>
@@ -32436,16 +32418,7 @@
                     </a:solidFill>
                     <a:latin typeface="Times New Roman"/>
                   </a:rPr>
-                  <a:t>O</a:t>
-                </a:r>
-                <a:r>
-                  <a:rPr lang="en-US" sz="1400" b="0" strike="noStrike" spc="-1" dirty="0">
-                    <a:solidFill>
-                      <a:schemeClr val="dk1"/>
-                    </a:solidFill>
-                    <a:latin typeface="Times New Roman"/>
-                  </a:rPr>
-                  <a:t>4</a:t>
+                  <a:t>O5</a:t>
                 </a:r>
                 <a:endParaRPr lang="en-DK" sz="1400" b="0" strike="noStrike" spc="-1" dirty="0">
                   <a:solidFill>
@@ -36960,16 +36933,7 @@
                   </a:solidFill>
                   <a:latin typeface="Times New Roman"/>
                 </a:rPr>
-                <a:t>O</a:t>
-              </a:r>
-              <a:r>
-                <a:rPr lang="en-US" sz="1400" b="0" strike="noStrike" spc="-1" dirty="0">
-                  <a:solidFill>
-                    <a:schemeClr val="dk1"/>
-                  </a:solidFill>
-                  <a:latin typeface="Times New Roman"/>
-                </a:rPr>
-                <a:t>4</a:t>
+                <a:t>O5</a:t>
               </a:r>
               <a:endParaRPr lang="en-DK" sz="1400" b="0" strike="noStrike" spc="-1" dirty="0">
                 <a:solidFill>

</xml_diff>